<commit_message>
docs(presentation): stop asserting the demonstration's subject split on slides 3 and 7
- Slide 3: the deck screenshots use synthetic training-split subjects; the published video's subject
  is stated as not independently verified.
- Slide 7: replace the training-split-only assertion with a repository-verifiable fact: the replay API
  never serves sealed test-split subjects (backend/serve_pr_tft.py, backend/tests/test_sealed_split_access.py).
- Speaker notes for slides 3 and 7 no longer claim the demonstration used training-split subjects only.
- docs/presentation/README.md slide descriptions updated to match.

HTML, PPTX and PDF re-synchronised; 14 slides / 14 pages. No code, model, result or protocol files changed.
</commit_message>
<xml_diff>
--- a/docs/presentation/presentation.pptx
+++ b/docs/presentation/presentation.pptx
@@ -1221,7 +1221,7 @@
           <a:p xmlns:a="http://schemas.openxmlformats.org/drawingml/2006/main"/>
           <a:p xmlns:a="http://schemas.openxmlformats.org/drawingml/2006/main">
             <a:r>
-              <a:t>SCREEN: Slide 3. Explain the cohort counts without opening any held-out files. The demonstration uses training-split subjects only; never select a test-split subject.</a:t>
+              <a:t>SCREEN: Slide 3. Explain the cohort counts without opening any held-out files. The deck screenshots use training-split subjects; do not assert which subject the published video shows.</a:t>
             </a:r>
           </a:p>
           <a:p xmlns:a="http://schemas.openxmlformats.org/drawingml/2006/main"/>
@@ -1233,7 +1233,7 @@
           <a:p xmlns:a="http://schemas.openxmlformats.org/drawingml/2006/main"/>
           <a:p xmlns:a="http://schemas.openxmlformats.org/drawingml/2006/main">
             <a:r>
-              <a:t>For this demonstration we use synthetic subjects from the training partition only. The screenshots in this deck show P0001 and P0095, both training-split subjects in the run's split file. That keeps the demonstration separate from held-out evaluation. We are replaying existing data, not collecting new data or generating a new cohort.</a:t>
+              <a:t>The screenshots in this deck show P0001 and P0095, both training-split subjects in the run's split file. The served application never lists or serves the sealed test split, so held-out evaluation stays separate from any demonstration. We are replaying existing data, not collecting new data or generating a new cohort.</a:t>
             </a:r>
           </a:p>
           <a:p xmlns:a="http://schemas.openxmlformats.org/drawingml/2006/main"/>
@@ -1657,13 +1657,13 @@
           <a:p xmlns:a="http://schemas.openxmlformats.org/drawingml/2006/main"/>
           <a:p xmlns:a="http://schemas.openxmlformats.org/drawingml/2006/main">
             <a:r>
-              <a:t>SCREEN: Switch from slide 7 to the application (http://127.0.0.1:3000/cohort). Select a training-split subject, confirm the Train label, and open its workspace. Read only the values that actually arrive: replay timestamp, current glucose, model mode and data status. Show at least two successive updates, then the interval and risk panels. Do not open test-split subjects. If no valid forecast arrives, say so rather than substituting fixtures.</a:t>
+              <a:t>SCREEN: Switch from slide 7 to the application (http://127.0.0.1:3000/cohort). Select a synthetic subject, read its split label aloud, and open its workspace. Sealed test-split subjects are not served. Read only the values that actually arrive: replay timestamp, current glucose, model mode and data status. Show at least two successive updates, then the interval and risk panels. Do not open test-split subjects. If no valid forecast arrives, say so rather than substituting fixtures.</a:t>
             </a:r>
           </a:p>
           <a:p xmlns:a="http://schemas.openxmlformats.org/drawingml/2006/main"/>
           <a:p xmlns:a="http://schemas.openxmlformats.org/drawingml/2006/main">
             <a:r>
-              <a:t>NIKHIL: We are now in the application. This is the synthetic cohort directory. I am selecting a synthetic subject from the training split. Before reading a forecast, I am checking the identity and the synthetic-data label.</a:t>
+              <a:t>NIKHIL: We are now in the application. This is the synthetic cohort directory. I am selecting a synthetic subject and reading its split label. Before reading a forecast, I am checking the identity and the synthetic-data label.</a:t>
             </a:r>
           </a:p>
           <a:p xmlns:a="http://schemas.openxmlformats.org/drawingml/2006/main"/>
@@ -14403,7 +14403,7 @@
                 <a:ea typeface="Arial"/>
                 <a:cs typeface="Arial"/>
               </a:rPr>
-              <a:t>Demonstration: training-split subjects only</a:t>
+              <a:t>Deck screenshots: synthetic training-split subjects. The published video's subject is not independently verified</a:t>
             </a:r>
           </a:p>
         </p:txBody>
@@ -19695,7 +19695,7 @@
                 <a:ea typeface="Arial"/>
                 <a:cs typeface="Arial"/>
               </a:rPr>
-              <a:t>Training-split subjects only; never the sealed test split</a:t>
+              <a:t>The replay API never serves sealed test-split subjects</a:t>
             </a:r>
           </a:p>
         </p:txBody>

</xml_diff>